<commit_message>
docs: update presentations for both challenges
</commit_message>
<xml_diff>
--- a/aca/TheContextractors_H4R2026_Ch11.pptx
+++ b/aca/TheContextractors_H4R2026_Ch11.pptx
@@ -333,7 +333,7 @@
           <a:p>
             <a:fld id="{47371D93-8784-4C02-8B2C-86355AB378F9}" type="slidenum">
               <a:rPr lang="de-DE" smtClean="0"/>
-              <a:t>‹Nr.›</a:t>
+              <a:t>‹#›</a:t>
             </a:fld>
             <a:endParaRPr lang="de-DE"/>
           </a:p>
@@ -533,7 +533,7 @@
           <a:p>
             <a:fld id="{47371D93-8784-4C02-8B2C-86355AB378F9}" type="slidenum">
               <a:rPr lang="de-DE" smtClean="0"/>
-              <a:t>‹Nr.›</a:t>
+              <a:t>‹#›</a:t>
             </a:fld>
             <a:endParaRPr lang="de-DE"/>
           </a:p>
@@ -743,7 +743,7 @@
           <a:p>
             <a:fld id="{47371D93-8784-4C02-8B2C-86355AB378F9}" type="slidenum">
               <a:rPr lang="de-DE" smtClean="0"/>
-              <a:t>‹Nr.›</a:t>
+              <a:t>‹#›</a:t>
             </a:fld>
             <a:endParaRPr lang="de-DE"/>
           </a:p>
@@ -943,7 +943,7 @@
           <a:p>
             <a:fld id="{47371D93-8784-4C02-8B2C-86355AB378F9}" type="slidenum">
               <a:rPr lang="de-DE" smtClean="0"/>
-              <a:t>‹Nr.›</a:t>
+              <a:t>‹#›</a:t>
             </a:fld>
             <a:endParaRPr lang="de-DE"/>
           </a:p>
@@ -1219,7 +1219,7 @@
           <a:p>
             <a:fld id="{47371D93-8784-4C02-8B2C-86355AB378F9}" type="slidenum">
               <a:rPr lang="de-DE" smtClean="0"/>
-              <a:t>‹Nr.›</a:t>
+              <a:t>‹#›</a:t>
             </a:fld>
             <a:endParaRPr lang="de-DE"/>
           </a:p>
@@ -1487,7 +1487,7 @@
           <a:p>
             <a:fld id="{47371D93-8784-4C02-8B2C-86355AB378F9}" type="slidenum">
               <a:rPr lang="de-DE" smtClean="0"/>
-              <a:t>‹Nr.›</a:t>
+              <a:t>‹#›</a:t>
             </a:fld>
             <a:endParaRPr lang="de-DE"/>
           </a:p>
@@ -1902,7 +1902,7 @@
           <a:p>
             <a:fld id="{47371D93-8784-4C02-8B2C-86355AB378F9}" type="slidenum">
               <a:rPr lang="de-DE" smtClean="0"/>
-              <a:t>‹Nr.›</a:t>
+              <a:t>‹#›</a:t>
             </a:fld>
             <a:endParaRPr lang="de-DE"/>
           </a:p>
@@ -2044,7 +2044,7 @@
           <a:p>
             <a:fld id="{47371D93-8784-4C02-8B2C-86355AB378F9}" type="slidenum">
               <a:rPr lang="de-DE" smtClean="0"/>
-              <a:t>‹Nr.›</a:t>
+              <a:t>‹#›</a:t>
             </a:fld>
             <a:endParaRPr lang="de-DE"/>
           </a:p>
@@ -2157,7 +2157,7 @@
           <a:p>
             <a:fld id="{47371D93-8784-4C02-8B2C-86355AB378F9}" type="slidenum">
               <a:rPr lang="de-DE" smtClean="0"/>
-              <a:t>‹Nr.›</a:t>
+              <a:t>‹#›</a:t>
             </a:fld>
             <a:endParaRPr lang="de-DE"/>
           </a:p>
@@ -2470,7 +2470,7 @@
           <a:p>
             <a:fld id="{47371D93-8784-4C02-8B2C-86355AB378F9}" type="slidenum">
               <a:rPr lang="de-DE" smtClean="0"/>
-              <a:t>‹Nr.›</a:t>
+              <a:t>‹#›</a:t>
             </a:fld>
             <a:endParaRPr lang="de-DE"/>
           </a:p>
@@ -2763,7 +2763,7 @@
           <a:p>
             <a:fld id="{47371D93-8784-4C02-8B2C-86355AB378F9}" type="slidenum">
               <a:rPr lang="de-DE" smtClean="0"/>
-              <a:t>‹Nr.›</a:t>
+              <a:t>‹#›</a:t>
             </a:fld>
             <a:endParaRPr lang="de-DE"/>
           </a:p>
@@ -3040,7 +3040,7 @@
           <a:p>
             <a:fld id="{47371D93-8784-4C02-8B2C-86355AB378F9}" type="slidenum">
               <a:rPr lang="de-DE" smtClean="0"/>
-              <a:t>‹Nr.›</a:t>
+              <a:t>‹#›</a:t>
             </a:fld>
             <a:endParaRPr lang="de-DE"/>
           </a:p>
@@ -3443,7 +3443,7 @@
           <a:p>
             <a:r>
               <a:rPr dirty="0"/>
-              <a:t>Hack4Rail 2026 – Team A38</a:t>
+              <a:t>Hack4Rail 2026</a:t>
             </a:r>
           </a:p>
         </p:txBody>
@@ -5804,27 +5804,6 @@
 </file>
 
 <file path=customXml/item1.xml><?xml version="1.0" encoding="utf-8"?>
-<?mso-contentType ?>
-<FormTemplates xmlns="http://schemas.microsoft.com/sharepoint/v3/contenttype/forms">
-  <Display>DocumentLibraryForm</Display>
-  <Edit>DocumentLibraryForm</Edit>
-  <New>DocumentLibraryForm</New>
-</FormTemplates>
-</file>
-
-<file path=customXml/item2.xml><?xml version="1.0" encoding="utf-8"?>
-<p:properties xmlns:p="http://schemas.microsoft.com/office/2006/metadata/properties" xmlns:xsi="http://www.w3.org/2001/XMLSchema-instance" xmlns:pc="http://schemas.microsoft.com/office/infopath/2007/PartnerControls">
-  <documentManagement>
-    <Copyright xmlns="b106c448-c3d1-41cc-8fd9-3acb307364b4" xsi:nil="true"/>
-    <lcf76f155ced4ddcb4097134ff3c332f xmlns="b106c448-c3d1-41cc-8fd9-3acb307364b4">
-      <Terms xmlns="http://schemas.microsoft.com/office/infopath/2007/PartnerControls"/>
-    </lcf76f155ced4ddcb4097134ff3c332f>
-    <TaxCatchAll xmlns="b043894e-b4c8-44d0-9690-d7947297ac19" xsi:nil="true"/>
-  </documentManagement>
-</p:properties>
-</file>
-
-<file path=customXml/item3.xml><?xml version="1.0" encoding="utf-8"?>
 <ct:contentTypeSchema xmlns:ct="http://schemas.microsoft.com/office/2006/metadata/contentType" xmlns:ma="http://schemas.microsoft.com/office/2006/metadata/properties/metaAttributes" ct:_="" ma:_="" ma:contentTypeName="Dokument" ma:contentTypeID="0x010100C5895299445B8C4DB378BBB718B1F939" ma:contentTypeVersion="18" ma:contentTypeDescription="Ein neues Dokument erstellen." ma:contentTypeScope="" ma:versionID="ca18c32604eb9eb075bdd5b520f76d7f">
   <xsd:schema xmlns:xsd="http://www.w3.org/2001/XMLSchema" xmlns:xs="http://www.w3.org/2001/XMLSchema" xmlns:p="http://schemas.microsoft.com/office/2006/metadata/properties" xmlns:ns2="b106c448-c3d1-41cc-8fd9-3acb307364b4" xmlns:ns3="b043894e-b4c8-44d0-9690-d7947297ac19" targetNamespace="http://schemas.microsoft.com/office/2006/metadata/properties" ma:root="true" ma:fieldsID="0e0a0918b2fa3636e306fde1bc5c258b" ns2:_="" ns3:_="">
     <xsd:import namespace="b106c448-c3d1-41cc-8fd9-3acb307364b4"/>
@@ -6069,10 +6048,42 @@
 </ct:contentTypeSchema>
 </file>
 
+<file path=customXml/item2.xml><?xml version="1.0" encoding="utf-8"?>
+<p:properties xmlns:p="http://schemas.microsoft.com/office/2006/metadata/properties" xmlns:xsi="http://www.w3.org/2001/XMLSchema-instance" xmlns:pc="http://schemas.microsoft.com/office/infopath/2007/PartnerControls">
+  <documentManagement>
+    <Copyright xmlns="b106c448-c3d1-41cc-8fd9-3acb307364b4" xsi:nil="true"/>
+    <lcf76f155ced4ddcb4097134ff3c332f xmlns="b106c448-c3d1-41cc-8fd9-3acb307364b4">
+      <Terms xmlns="http://schemas.microsoft.com/office/infopath/2007/PartnerControls"/>
+    </lcf76f155ced4ddcb4097134ff3c332f>
+    <TaxCatchAll xmlns="b043894e-b4c8-44d0-9690-d7947297ac19" xsi:nil="true"/>
+  </documentManagement>
+</p:properties>
+</file>
+
+<file path=customXml/item3.xml><?xml version="1.0" encoding="utf-8"?>
+<?mso-contentType ?>
+<FormTemplates xmlns="http://schemas.microsoft.com/sharepoint/v3/contenttype/forms">
+  <Display>DocumentLibraryForm</Display>
+  <Edit>DocumentLibraryForm</Edit>
+  <New>DocumentLibraryForm</New>
+</FormTemplates>
+</file>
+
 <file path=customXml/itemProps1.xml><?xml version="1.0" encoding="utf-8"?>
-<ds:datastoreItem xmlns:ds="http://schemas.openxmlformats.org/officeDocument/2006/customXml" ds:itemID="{47CF5FD6-43E2-4C9A-9372-C9D60EE1772B}">
+<ds:datastoreItem xmlns:ds="http://schemas.openxmlformats.org/officeDocument/2006/customXml" ds:itemID="{0BED3A9D-D1E4-45EA-8B49-CB6F60C2A98A}">
   <ds:schemaRefs>
-    <ds:schemaRef ds:uri="http://schemas.microsoft.com/sharepoint/v3/contenttype/forms"/>
+    <ds:schemaRef ds:uri="http://schemas.microsoft.com/office/2006/metadata/contentType"/>
+    <ds:schemaRef ds:uri="http://schemas.microsoft.com/office/2006/metadata/properties/metaAttributes"/>
+    <ds:schemaRef ds:uri="http://www.w3.org/2001/XMLSchema"/>
+    <ds:schemaRef ds:uri="http://schemas.microsoft.com/office/2006/metadata/properties"/>
+    <ds:schemaRef ds:uri="b106c448-c3d1-41cc-8fd9-3acb307364b4"/>
+    <ds:schemaRef ds:uri="b043894e-b4c8-44d0-9690-d7947297ac19"/>
+    <ds:schemaRef ds:uri="http://schemas.microsoft.com/office/2006/documentManagement/types"/>
+    <ds:schemaRef ds:uri="http://schemas.microsoft.com/office/infopath/2007/PartnerControls"/>
+    <ds:schemaRef ds:uri="http://schemas.openxmlformats.org/package/2006/metadata/core-properties"/>
+    <ds:schemaRef ds:uri="http://purl.org/dc/elements/1.1/"/>
+    <ds:schemaRef ds:uri="http://purl.org/dc/terms/"/>
+    <ds:schemaRef ds:uri="http://schemas.microsoft.com/internal/obd"/>
   </ds:schemaRefs>
 </ds:datastoreItem>
 </file>
@@ -6095,20 +6106,9 @@
 </file>
 
 <file path=customXml/itemProps3.xml><?xml version="1.0" encoding="utf-8"?>
-<ds:datastoreItem xmlns:ds="http://schemas.openxmlformats.org/officeDocument/2006/customXml" ds:itemID="{0BED3A9D-D1E4-45EA-8B49-CB6F60C2A98A}">
+<ds:datastoreItem xmlns:ds="http://schemas.openxmlformats.org/officeDocument/2006/customXml" ds:itemID="{47CF5FD6-43E2-4C9A-9372-C9D60EE1772B}">
   <ds:schemaRefs>
-    <ds:schemaRef ds:uri="http://schemas.microsoft.com/office/2006/metadata/contentType"/>
-    <ds:schemaRef ds:uri="http://schemas.microsoft.com/office/2006/metadata/properties/metaAttributes"/>
-    <ds:schemaRef ds:uri="http://www.w3.org/2001/XMLSchema"/>
-    <ds:schemaRef ds:uri="http://schemas.microsoft.com/office/2006/metadata/properties"/>
-    <ds:schemaRef ds:uri="b106c448-c3d1-41cc-8fd9-3acb307364b4"/>
-    <ds:schemaRef ds:uri="b043894e-b4c8-44d0-9690-d7947297ac19"/>
-    <ds:schemaRef ds:uri="http://schemas.microsoft.com/office/2006/documentManagement/types"/>
-    <ds:schemaRef ds:uri="http://schemas.microsoft.com/office/infopath/2007/PartnerControls"/>
-    <ds:schemaRef ds:uri="http://schemas.openxmlformats.org/package/2006/metadata/core-properties"/>
-    <ds:schemaRef ds:uri="http://purl.org/dc/elements/1.1/"/>
-    <ds:schemaRef ds:uri="http://purl.org/dc/terms/"/>
-    <ds:schemaRef ds:uri="http://schemas.microsoft.com/internal/obd"/>
+    <ds:schemaRef ds:uri="http://schemas.microsoft.com/sharepoint/v3/contenttype/forms"/>
   </ds:schemaRefs>
 </ds:datastoreItem>
 </file>

</xml_diff>